<commit_message>
Rebalance workload: give Mame Fatou substantial hands-on tasks
She now owns: certificate revocation/CRL demo in EJBCA, independent TLS
security audit (testssl.sh/nmap), and the private-vs-public CA
comparison, in addition to compiling the final report/PPT and video.
Ahmad and Papa each write their own report section instead of dumping
all documentation on Mame Fatou.
</commit_message>
<xml_diff>
--- a/GROUPE-2/Presentation_PKI_EJBCA_GROUPE-2.pptx
+++ b/GROUPE-2/Presentation_PKI_EJBCA_GROUPE-2.pptx
@@ -23,6 +23,8 @@
     <p:sldId id="271" r:id="rId22"/>
     <p:sldId id="272" r:id="rId23"/>
     <p:sldId id="273" r:id="rId24"/>
+    <p:sldId id="274" r:id="rId25"/>
+    <p:sldId id="275" r:id="rId26"/>
   </p:sldIdLst>
   <p:sldSz cx="12188952" cy="6858000" type="screen4x3"/>
   <p:notesSz cx="6858000" cy="9144000"/>
@@ -3740,18 +3742,6 @@
               <a:t>Vérification de la redirection HTTP → HTTPS</a:t>
             </a:r>
           </a:p>
-          <a:p>
-            <a:pPr>
-              <a:defRPr sz="2000">
-                <a:solidFill>
-                  <a:srgbClr val="222222"/>
-                </a:solidFill>
-              </a:defRPr>
-            </a:pPr>
-            <a:r>
-              <a:t>(Bonus) Révocation d'un certificat et vérification via la CRL</a:t>
-            </a:r>
-          </a:p>
         </p:txBody>
       </p:sp>
     </p:spTree>
@@ -3895,7 +3885,7 @@
               </a:defRPr>
             </a:pPr>
             <a:r>
-              <a:t>Difficultés rencontrées</a:t>
+              <a:t>Audit indépendant — Mame Fatou</a:t>
             </a:r>
           </a:p>
         </p:txBody>
@@ -3930,7 +3920,7 @@
               </a:defRPr>
             </a:pPr>
             <a:r>
-              <a:t>[À compléter : ex. format des SAN, chaîne de certificats incomplète, ports déjà utilisés...]</a:t>
+              <a:t>Révocation du certificat serveur dans EJBCA + vérification de la CRL</a:t>
             </a:r>
           </a:p>
           <a:p>
@@ -3942,7 +3932,31 @@
               </a:defRPr>
             </a:pPr>
             <a:r>
-              <a:t>[Solution apportée pour chaque difficulté]</a:t>
+              <a:t>Audit de sécurité TLS indépendant : testssl.sh / nmap ssl-enum-ciphers</a:t>
+            </a:r>
+          </a:p>
+          <a:p>
+            <a:pPr>
+              <a:defRPr sz="2000">
+                <a:solidFill>
+                  <a:srgbClr val="222222"/>
+                </a:solidFill>
+              </a:defRPr>
+            </a:pPr>
+            <a:r>
+              <a:t>Comparatif CA privée (EJBCA) vs CA publique (ex. google.com)</a:t>
+            </a:r>
+          </a:p>
+          <a:p>
+            <a:pPr>
+              <a:defRPr sz="2000">
+                <a:solidFill>
+                  <a:srgbClr val="222222"/>
+                </a:solidFill>
+              </a:defRPr>
+            </a:pPr>
+            <a:r>
+              <a:t>Objectif : validation croisée, indépendante de la personne ayant configuré le serveur</a:t>
             </a:r>
           </a:p>
         </p:txBody>
@@ -3988,90 +4002,61 @@
               </a:defRPr>
             </a:pPr>
             <a:r>
-              <a:t>Perspectives</a:t>
-            </a:r>
-          </a:p>
-        </p:txBody>
-      </p:sp>
-      <p:sp>
-        <p:nvSpPr>
-          <p:cNvPr id="3" name="TextBox 2"/>
-          <p:cNvSpPr txBox="1"/>
+              <a:t>Audit indépendant — Mame Fatou</a:t>
+            </a:r>
+          </a:p>
+        </p:txBody>
+      </p:sp>
+      <p:sp>
+        <p:nvSpPr>
+          <p:cNvPr id="3" name="Rectangle 2"/>
+          <p:cNvSpPr/>
           <p:nvPr/>
         </p:nvSpPr>
         <p:spPr>
           <a:xfrm>
-            <a:off x="731520" y="1463040"/>
-            <a:ext cx="10698480" cy="4846320"/>
+            <a:off x="1371600" y="1645920"/>
+            <a:ext cx="9418320" cy="4389120"/>
           </a:xfrm>
           <a:prstGeom prst="rect">
             <a:avLst/>
           </a:prstGeom>
-          <a:noFill/>
+          <a:solidFill>
+            <a:srgbClr val="F2F2F2"/>
+          </a:solidFill>
+          <a:ln>
+            <a:solidFill>
+              <a:srgbClr val="BBBBBB"/>
+            </a:solidFill>
+          </a:ln>
         </p:spPr>
-        <p:txBody>
-          <a:bodyPr wrap="square">
-            <a:spAutoFit/>
-          </a:bodyPr>
-          <a:lstStyle/>
-          <a:p>
-            <a:pPr>
-              <a:defRPr sz="2000">
-                <a:solidFill>
-                  <a:srgbClr val="222222"/>
-                </a:solidFill>
-              </a:defRPr>
-            </a:pPr>
-            <a:r>
-              <a:t>Automatisation via ACME/EST/SCEP</a:t>
-            </a:r>
-          </a:p>
-          <a:p>
-            <a:pPr>
-              <a:defRPr sz="2000">
-                <a:solidFill>
-                  <a:srgbClr val="222222"/>
-                </a:solidFill>
-              </a:defRPr>
-            </a:pPr>
-            <a:r>
-              <a:t>Réduction de la durée de vie des certificats (tendance CA/Browser Forum)</a:t>
-            </a:r>
-          </a:p>
-          <a:p>
-            <a:pPr>
-              <a:defRPr sz="2000">
-                <a:solidFill>
-                  <a:srgbClr val="222222"/>
-                </a:solidFill>
-              </a:defRPr>
-            </a:pPr>
-            <a:r>
-              <a:t>Crypto-agilité et migration post-quantique (ML-KEM, ML-DSA, SLH-DSA)</a:t>
-            </a:r>
-          </a:p>
-          <a:p>
-            <a:pPr>
-              <a:defRPr sz="2000">
-                <a:solidFill>
-                  <a:srgbClr val="222222"/>
-                </a:solidFill>
-              </a:defRPr>
-            </a:pPr>
-            <a:r>
-              <a:t>OCSP responder pour révocation en temps quasi réel</a:t>
-            </a:r>
-          </a:p>
-          <a:p>
-            <a:pPr>
-              <a:defRPr sz="2000">
-                <a:solidFill>
-                  <a:srgbClr val="222222"/>
-                </a:solidFill>
-              </a:defRPr>
-            </a:pPr>
-            <a:r>
-              <a:t>Architecture Root CA hors ligne / Sub CA en ligne pour la production</a:t>
+        <p:style>
+          <a:lnRef idx="1">
+            <a:schemeClr val="accent1"/>
+          </a:lnRef>
+          <a:fillRef idx="3">
+            <a:schemeClr val="accent1"/>
+          </a:fillRef>
+          <a:effectRef idx="2">
+            <a:schemeClr val="accent1"/>
+          </a:effectRef>
+          <a:fontRef idx="minor">
+            <a:schemeClr val="lt1"/>
+          </a:fontRef>
+        </p:style>
+        <p:txBody>
+          <a:bodyPr rtlCol="0" anchor="ctr" wrap="square"/>
+          <a:lstStyle/>
+          <a:p>
+            <a:pPr algn="ctr">
+              <a:defRPr i="1" sz="1600">
+                <a:solidFill>
+                  <a:srgbClr val="808080"/>
+                </a:solidFill>
+              </a:defRPr>
+            </a:pPr>
+            <a:r>
+              <a:t>[ Insérer capture d'écran : Révocation + CRL, résultat testssl.sh, comparatif curl ]</a:t>
             </a:r>
           </a:p>
         </p:txBody>
@@ -4117,7 +4102,7 @@
               </a:defRPr>
             </a:pPr>
             <a:r>
-              <a:t>Conclusion</a:t>
+              <a:t>Difficultés rencontrées</a:t>
             </a:r>
           </a:p>
         </p:txBody>
@@ -4152,7 +4137,7 @@
               </a:defRPr>
             </a:pPr>
             <a:r>
-              <a:t>PKI privée déployée avec EJBCA : Root CA, certificat serveur émis</a:t>
+              <a:t>[À compléter : ex. format des SAN, chaîne de certificats incomplète, ports déjà utilisés...]</a:t>
             </a:r>
           </a:p>
           <a:p>
@@ -4164,9 +4149,78 @@
               </a:defRPr>
             </a:pPr>
             <a:r>
-              <a:t>Migration effective d'un service web de HTTP vers HTTPS</a:t>
-            </a:r>
-          </a:p>
+              <a:t>[Solution apportée pour chaque difficulté]</a:t>
+            </a:r>
+          </a:p>
+        </p:txBody>
+      </p:sp>
+    </p:spTree>
+  </p:cSld>
+  <p:clrMapOvr>
+    <a:masterClrMapping/>
+  </p:clrMapOvr>
+</p:sld>
+</file>
+
+<file path=ppt/slides/slide19.xml><?xml version="1.0" encoding="utf-8"?>
+<p:sld xmlns:a="http://schemas.openxmlformats.org/drawingml/2006/main" xmlns:p="http://schemas.openxmlformats.org/presentationml/2006/main" xmlns:r="http://schemas.openxmlformats.org/officeDocument/2006/relationships">
+  <p:cSld>
+    <p:spTree>
+      <p:nvGrpSpPr>
+        <p:cNvPr id="1" name=""/>
+        <p:cNvGrpSpPr/>
+        <p:nvPr/>
+      </p:nvGrpSpPr>
+      <p:grpSpPr/>
+      <p:sp>
+        <p:nvSpPr>
+          <p:cNvPr id="2" name="Title 1"/>
+          <p:cNvSpPr>
+            <a:spLocks noGrp="1"/>
+          </p:cNvSpPr>
+          <p:nvPr>
+            <p:ph type="title"/>
+          </p:nvPr>
+        </p:nvSpPr>
+        <p:spPr/>
+        <p:txBody>
+          <a:bodyPr/>
+          <a:lstStyle/>
+          <a:p>
+            <a:pPr>
+              <a:defRPr sz="3000">
+                <a:solidFill>
+                  <a:srgbClr val="1B2A41"/>
+                </a:solidFill>
+              </a:defRPr>
+            </a:pPr>
+            <a:r>
+              <a:t>Perspectives</a:t>
+            </a:r>
+          </a:p>
+        </p:txBody>
+      </p:sp>
+      <p:sp>
+        <p:nvSpPr>
+          <p:cNvPr id="3" name="TextBox 2"/>
+          <p:cNvSpPr txBox="1"/>
+          <p:nvPr/>
+        </p:nvSpPr>
+        <p:spPr>
+          <a:xfrm>
+            <a:off x="731520" y="1463040"/>
+            <a:ext cx="10698480" cy="4846320"/>
+          </a:xfrm>
+          <a:prstGeom prst="rect">
+            <a:avLst/>
+          </a:prstGeom>
+          <a:noFill/>
+        </p:spPr>
+        <p:txBody>
+          <a:bodyPr wrap="square">
+            <a:spAutoFit/>
+          </a:bodyPr>
+          <a:lstStyle/>
           <a:p>
             <a:pPr>
               <a:defRPr sz="2000">
@@ -4176,7 +4230,7 @@
               </a:defRPr>
             </a:pPr>
             <a:r>
-              <a:t>Mise en pratique concrète des concepts de cryptographie asymétrique et de confiance numérique</a:t>
+              <a:t>Automatisation via ACME/EST/SCEP</a:t>
             </a:r>
           </a:p>
           <a:p>
@@ -4188,7 +4242,43 @@
               </a:defRPr>
             </a:pPr>
             <a:r>
-              <a:t>Merci de votre attention — Questions ?</a:t>
+              <a:t>Réduction de la durée de vie des certificats (tendance CA/Browser Forum)</a:t>
+            </a:r>
+          </a:p>
+          <a:p>
+            <a:pPr>
+              <a:defRPr sz="2000">
+                <a:solidFill>
+                  <a:srgbClr val="222222"/>
+                </a:solidFill>
+              </a:defRPr>
+            </a:pPr>
+            <a:r>
+              <a:t>Crypto-agilité et migration post-quantique (ML-KEM, ML-DSA, SLH-DSA)</a:t>
+            </a:r>
+          </a:p>
+          <a:p>
+            <a:pPr>
+              <a:defRPr sz="2000">
+                <a:solidFill>
+                  <a:srgbClr val="222222"/>
+                </a:solidFill>
+              </a:defRPr>
+            </a:pPr>
+            <a:r>
+              <a:t>OCSP responder pour révocation en temps quasi réel</a:t>
+            </a:r>
+          </a:p>
+          <a:p>
+            <a:pPr>
+              <a:defRPr sz="2000">
+                <a:solidFill>
+                  <a:srgbClr val="222222"/>
+                </a:solidFill>
+              </a:defRPr>
+            </a:pPr>
+            <a:r>
+              <a:t>Architecture Root CA hors ligne / Sub CA en ligne pour la production</a:t>
             </a:r>
           </a:p>
         </p:txBody>
@@ -4354,6 +4444,123 @@
             </a:pPr>
             <a:r>
               <a:t>Conclusion</a:t>
+            </a:r>
+          </a:p>
+        </p:txBody>
+      </p:sp>
+    </p:spTree>
+  </p:cSld>
+  <p:clrMapOvr>
+    <a:masterClrMapping/>
+  </p:clrMapOvr>
+</p:sld>
+</file>
+
+<file path=ppt/slides/slide20.xml><?xml version="1.0" encoding="utf-8"?>
+<p:sld xmlns:a="http://schemas.openxmlformats.org/drawingml/2006/main" xmlns:p="http://schemas.openxmlformats.org/presentationml/2006/main" xmlns:r="http://schemas.openxmlformats.org/officeDocument/2006/relationships">
+  <p:cSld>
+    <p:spTree>
+      <p:nvGrpSpPr>
+        <p:cNvPr id="1" name=""/>
+        <p:cNvGrpSpPr/>
+        <p:nvPr/>
+      </p:nvGrpSpPr>
+      <p:grpSpPr/>
+      <p:sp>
+        <p:nvSpPr>
+          <p:cNvPr id="2" name="Title 1"/>
+          <p:cNvSpPr>
+            <a:spLocks noGrp="1"/>
+          </p:cNvSpPr>
+          <p:nvPr>
+            <p:ph type="title"/>
+          </p:nvPr>
+        </p:nvSpPr>
+        <p:spPr/>
+        <p:txBody>
+          <a:bodyPr/>
+          <a:lstStyle/>
+          <a:p>
+            <a:pPr>
+              <a:defRPr sz="3000">
+                <a:solidFill>
+                  <a:srgbClr val="1B2A41"/>
+                </a:solidFill>
+              </a:defRPr>
+            </a:pPr>
+            <a:r>
+              <a:t>Conclusion</a:t>
+            </a:r>
+          </a:p>
+        </p:txBody>
+      </p:sp>
+      <p:sp>
+        <p:nvSpPr>
+          <p:cNvPr id="3" name="TextBox 2"/>
+          <p:cNvSpPr txBox="1"/>
+          <p:nvPr/>
+        </p:nvSpPr>
+        <p:spPr>
+          <a:xfrm>
+            <a:off x="731520" y="1463040"/>
+            <a:ext cx="10698480" cy="4846320"/>
+          </a:xfrm>
+          <a:prstGeom prst="rect">
+            <a:avLst/>
+          </a:prstGeom>
+          <a:noFill/>
+        </p:spPr>
+        <p:txBody>
+          <a:bodyPr wrap="square">
+            <a:spAutoFit/>
+          </a:bodyPr>
+          <a:lstStyle/>
+          <a:p>
+            <a:pPr>
+              <a:defRPr sz="2000">
+                <a:solidFill>
+                  <a:srgbClr val="222222"/>
+                </a:solidFill>
+              </a:defRPr>
+            </a:pPr>
+            <a:r>
+              <a:t>PKI privée déployée avec EJBCA : Root CA, certificat serveur émis</a:t>
+            </a:r>
+          </a:p>
+          <a:p>
+            <a:pPr>
+              <a:defRPr sz="2000">
+                <a:solidFill>
+                  <a:srgbClr val="222222"/>
+                </a:solidFill>
+              </a:defRPr>
+            </a:pPr>
+            <a:r>
+              <a:t>Migration effective d'un service web de HTTP vers HTTPS</a:t>
+            </a:r>
+          </a:p>
+          <a:p>
+            <a:pPr>
+              <a:defRPr sz="2000">
+                <a:solidFill>
+                  <a:srgbClr val="222222"/>
+                </a:solidFill>
+              </a:defRPr>
+            </a:pPr>
+            <a:r>
+              <a:t>Mise en pratique concrète des concepts de cryptographie asymétrique et de confiance numérique</a:t>
+            </a:r>
+          </a:p>
+          <a:p>
+            <a:pPr>
+              <a:defRPr sz="2000">
+                <a:solidFill>
+                  <a:srgbClr val="222222"/>
+                </a:solidFill>
+              </a:defRPr>
+            </a:pPr>
+            <a:r>
+              <a:t>Merci de votre attention — Questions ?</a:t>
             </a:r>
           </a:p>
         </p:txBody>

</xml_diff>

<commit_message>
fix: correct team member name Mame Fatou -> Mame Fama
</commit_message>
<xml_diff>
--- a/GROUPE-2/Presentation_PKI_EJBCA_GROUPE-2.pptx
+++ b/GROUPE-2/Presentation_PKI_EJBCA_GROUPE-2.pptx
@@ -3200,7 +3200,7 @@
               </a:defRPr>
             </a:pPr>
             <a:r>
-              <a:t>Ahmad Diop · Papa Mamadou · Mame Fatou</a:t>
+              <a:t>Ahmad Diop · Papa Mamadou · Mame Fama</a:t>
             </a:r>
           </a:p>
         </p:txBody>
@@ -3885,7 +3885,7 @@
               </a:defRPr>
             </a:pPr>
             <a:r>
-              <a:t>Audit indépendant — Mame Fatou</a:t>
+              <a:t>Audit indépendant — Mame Fama</a:t>
             </a:r>
           </a:p>
         </p:txBody>
@@ -4002,7 +4002,7 @@
               </a:defRPr>
             </a:pPr>
             <a:r>
-              <a:t>Audit indépendant — Mame Fatou</a:t>
+              <a:t>Audit indépendant — Mame Fama</a:t>
             </a:r>
           </a:p>
         </p:txBody>

</xml_diff>